<commit_message>
Module 1 v2 : Enterprise Blue, corrections lisibilité et chevauchements (S10/S13 sous-titre, S3 statBox)
</commit_message>
<xml_diff>
--- a/module-01-culture-devops/Formation-DevOps-Module-01-Culture.pptx
+++ b/module-01-culture-devops/Formation-DevOps-Module-01-Culture.pptx
@@ -3023,45 +3023,6 @@
         </p:nvSpPr>
         <p:spPr>
           <a:xfrm>
-            <a:off x="502920" y="1691640"/>
-            <a:ext cx="10515600" cy="365760"/>
-          </a:xfrm>
-          <a:prstGeom prst="rect">
-            <a:avLst/>
-          </a:prstGeom>
-          <a:noFill/>
-          <a:ln/>
-        </p:spPr>
-        <p:txBody>
-          <a:bodyPr wrap="square" lIns="0" tIns="0" rIns="0" bIns="0" rtlCol="0" anchor="ctr"/>
-          <a:lstStyle/>
-          <a:p>
-            <a:pPr indent="0" marL="0">
-              <a:buNone/>
-            </a:pPr>
-            <a:r>
-              <a:rPr lang="en-US" sz="1500" dirty="0">
-                <a:solidFill>
-                  <a:srgbClr val="64748B"/>
-                </a:solidFill>
-                <a:latin typeface="Calibri" pitchFamily="34" charset="0"/>
-                <a:ea typeface="Calibri" pitchFamily="34" charset="-122"/>
-                <a:cs typeface="Calibri" pitchFamily="34" charset="-120"/>
-              </a:rPr>
-              <a:t>On ne jette rien : on déplace la rigueur existante vers de nouveaux outils.</a:t>
-            </a:r>
-            <a:endParaRPr lang="en-US" sz="1500" dirty="0"/>
-          </a:p>
-        </p:txBody>
-      </p:sp>
-      <p:sp>
-        <p:nvSpPr>
-          <p:cNvPr id="7" name="Text 5"/>
-          <p:cNvSpPr/>
-          <p:nvPr/>
-        </p:nvSpPr>
-        <p:spPr>
-          <a:xfrm>
             <a:off x="502920" y="6492240"/>
             <a:ext cx="8229600" cy="256032"/>
           </a:xfrm>
@@ -3095,7 +3056,7 @@
       </p:sp>
       <p:sp>
         <p:nvSpPr>
-          <p:cNvPr id="8" name="Text 6"/>
+          <p:cNvPr id="7" name="Text 5"/>
           <p:cNvSpPr/>
           <p:nvPr/>
         </p:nvSpPr>
@@ -3134,7 +3095,7 @@
       </p:sp>
       <p:sp>
         <p:nvSpPr>
-          <p:cNvPr id="9" name="Shape 7"/>
+          <p:cNvPr id="8" name="Shape 6"/>
           <p:cNvSpPr/>
           <p:nvPr/>
         </p:nvSpPr>
@@ -3168,7 +3129,7 @@
       </p:sp>
       <p:sp>
         <p:nvSpPr>
-          <p:cNvPr id="10" name="Text 8"/>
+          <p:cNvPr id="9" name="Text 7"/>
           <p:cNvSpPr/>
           <p:nvPr/>
         </p:nvSpPr>
@@ -3207,7 +3168,7 @@
       </p:sp>
       <p:sp>
         <p:nvSpPr>
-          <p:cNvPr id="11" name="Text 9"/>
+          <p:cNvPr id="10" name="Text 8"/>
           <p:cNvSpPr/>
           <p:nvPr/>
         </p:nvSpPr>
@@ -3349,7 +3310,7 @@
       </p:sp>
       <p:sp>
         <p:nvSpPr>
-          <p:cNvPr id="12" name="Shape 10"/>
+          <p:cNvPr id="11" name="Shape 9"/>
           <p:cNvSpPr/>
           <p:nvPr/>
         </p:nvSpPr>
@@ -3383,7 +3344,7 @@
       </p:sp>
       <p:sp>
         <p:nvSpPr>
-          <p:cNvPr id="13" name="Text 11"/>
+          <p:cNvPr id="12" name="Text 10"/>
           <p:cNvSpPr/>
           <p:nvPr/>
         </p:nvSpPr>
@@ -3422,7 +3383,7 @@
       </p:sp>
       <p:sp>
         <p:nvSpPr>
-          <p:cNvPr id="14" name="Text 12"/>
+          <p:cNvPr id="13" name="Text 11"/>
           <p:cNvSpPr/>
           <p:nvPr/>
         </p:nvSpPr>
@@ -3564,7 +3525,7 @@
       </p:sp>
       <p:sp>
         <p:nvSpPr>
-          <p:cNvPr id="15" name="Shape 13"/>
+          <p:cNvPr id="14" name="Shape 12"/>
           <p:cNvSpPr/>
           <p:nvPr/>
         </p:nvSpPr>
@@ -3598,7 +3559,7 @@
       </p:sp>
       <p:sp>
         <p:nvSpPr>
-          <p:cNvPr id="16" name="Text 14"/>
+          <p:cNvPr id="15" name="Text 13"/>
           <p:cNvSpPr/>
           <p:nvPr/>
         </p:nvSpPr>
@@ -5845,45 +5806,6 @@
         </p:nvSpPr>
         <p:spPr>
           <a:xfrm>
-            <a:off x="502920" y="1691640"/>
-            <a:ext cx="10515600" cy="365760"/>
-          </a:xfrm>
-          <a:prstGeom prst="rect">
-            <a:avLst/>
-          </a:prstGeom>
-          <a:noFill/>
-          <a:ln/>
-        </p:spPr>
-        <p:txBody>
-          <a:bodyPr wrap="square" lIns="0" tIns="0" rIns="0" bIns="0" rtlCol="0" anchor="ctr"/>
-          <a:lstStyle/>
-          <a:p>
-            <a:pPr indent="0" marL="0">
-              <a:buNone/>
-            </a:pPr>
-            <a:r>
-              <a:rPr lang="en-US" sz="1500" dirty="0">
-                <a:solidFill>
-                  <a:srgbClr val="64748B"/>
-                </a:solidFill>
-                <a:latin typeface="Calibri" pitchFamily="34" charset="0"/>
-                <a:ea typeface="Calibri" pitchFamily="34" charset="-122"/>
-                <a:cs typeface="Calibri" pitchFamily="34" charset="-120"/>
-              </a:rPr>
-              <a:t>La performance d'une équipe se mesure, pas se devine.</a:t>
-            </a:r>
-            <a:endParaRPr lang="en-US" sz="1500" dirty="0"/>
-          </a:p>
-        </p:txBody>
-      </p:sp>
-      <p:sp>
-        <p:nvSpPr>
-          <p:cNvPr id="7" name="Text 5"/>
-          <p:cNvSpPr/>
-          <p:nvPr/>
-        </p:nvSpPr>
-        <p:spPr>
-          <a:xfrm>
             <a:off x="502920" y="6492240"/>
             <a:ext cx="8229600" cy="256032"/>
           </a:xfrm>
@@ -5917,7 +5839,7 @@
       </p:sp>
       <p:sp>
         <p:nvSpPr>
-          <p:cNvPr id="8" name="Text 6"/>
+          <p:cNvPr id="7" name="Text 5"/>
           <p:cNvSpPr/>
           <p:nvPr/>
         </p:nvSpPr>
@@ -5956,7 +5878,7 @@
       </p:sp>
       <p:sp>
         <p:nvSpPr>
-          <p:cNvPr id="9" name="Shape 7"/>
+          <p:cNvPr id="8" name="Shape 6"/>
           <p:cNvSpPr/>
           <p:nvPr/>
         </p:nvSpPr>
@@ -5990,7 +5912,7 @@
       </p:sp>
       <p:sp>
         <p:nvSpPr>
-          <p:cNvPr id="10" name="Shape 8"/>
+          <p:cNvPr id="9" name="Shape 7"/>
           <p:cNvSpPr/>
           <p:nvPr/>
         </p:nvSpPr>
@@ -6012,13 +5934,52 @@
       </p:sp>
       <p:sp>
         <p:nvSpPr>
+          <p:cNvPr id="10" name="Text 8"/>
+          <p:cNvSpPr/>
+          <p:nvPr/>
+        </p:nvSpPr>
+        <p:spPr>
+          <a:xfrm>
+            <a:off x="685800" y="2029968"/>
+            <a:ext cx="2350008" cy="640080"/>
+          </a:xfrm>
+          <a:prstGeom prst="rect">
+            <a:avLst/>
+          </a:prstGeom>
+          <a:noFill/>
+          <a:ln/>
+        </p:spPr>
+        <p:txBody>
+          <a:bodyPr wrap="square" lIns="0" tIns="0" rIns="0" bIns="0" rtlCol="0" anchor="ctr"/>
+          <a:lstStyle/>
+          <a:p>
+            <a:pPr indent="0" marL="0">
+              <a:buNone/>
+            </a:pPr>
+            <a:r>
+              <a:rPr lang="en-US" sz="3000" b="1" dirty="0">
+                <a:solidFill>
+                  <a:srgbClr val="EA580C"/>
+                </a:solidFill>
+                <a:latin typeface="Calibri" pitchFamily="34" charset="0"/>
+                <a:ea typeface="Calibri" pitchFamily="34" charset="-122"/>
+                <a:cs typeface="Calibri" pitchFamily="34" charset="-120"/>
+              </a:rPr>
+              <a:t>À la demande</a:t>
+            </a:r>
+            <a:endParaRPr lang="en-US" sz="3000" dirty="0"/>
+          </a:p>
+        </p:txBody>
+      </p:sp>
+      <p:sp>
+        <p:nvSpPr>
           <p:cNvPr id="11" name="Text 9"/>
           <p:cNvSpPr/>
           <p:nvPr/>
         </p:nvSpPr>
         <p:spPr>
           <a:xfrm>
-            <a:off x="685800" y="2029968"/>
+            <a:off x="685800" y="2724912"/>
             <a:ext cx="2350008" cy="685800"/>
           </a:xfrm>
           <a:prstGeom prst="rect">
@@ -6035,62 +5996,23 @@
               <a:buNone/>
             </a:pPr>
             <a:r>
-              <a:rPr lang="en-US" sz="3000" b="1" dirty="0">
-                <a:solidFill>
-                  <a:srgbClr val="EA580C"/>
-                </a:solidFill>
-                <a:latin typeface="Calibri" pitchFamily="34" charset="0"/>
-                <a:ea typeface="Calibri" pitchFamily="34" charset="-122"/>
-                <a:cs typeface="Calibri" pitchFamily="34" charset="-120"/>
-              </a:rPr>
-              <a:t>À la demande</a:t>
-            </a:r>
-            <a:endParaRPr lang="en-US" sz="3000" dirty="0"/>
+              <a:rPr lang="en-US" sz="1200" dirty="0">
+                <a:solidFill>
+                  <a:srgbClr val="334155"/>
+                </a:solidFill>
+                <a:latin typeface="Calibri" pitchFamily="34" charset="0"/>
+                <a:ea typeface="Calibri" pitchFamily="34" charset="-122"/>
+                <a:cs typeface="Calibri" pitchFamily="34" charset="-120"/>
+              </a:rPr>
+              <a:t>Deployment Frequency</a:t>
+            </a:r>
+            <a:endParaRPr lang="en-US" sz="1200" dirty="0"/>
           </a:p>
         </p:txBody>
       </p:sp>
       <p:sp>
         <p:nvSpPr>
           <p:cNvPr id="12" name="Text 10"/>
-          <p:cNvSpPr/>
-          <p:nvPr/>
-        </p:nvSpPr>
-        <p:spPr>
-          <a:xfrm>
-            <a:off x="685800" y="2761488"/>
-            <a:ext cx="2350008" cy="685800"/>
-          </a:xfrm>
-          <a:prstGeom prst="rect">
-            <a:avLst/>
-          </a:prstGeom>
-          <a:noFill/>
-          <a:ln/>
-        </p:spPr>
-        <p:txBody>
-          <a:bodyPr wrap="square" lIns="0" tIns="0" rIns="0" bIns="0" rtlCol="0" anchor="ctr"/>
-          <a:lstStyle/>
-          <a:p>
-            <a:pPr indent="0" marL="0">
-              <a:buNone/>
-            </a:pPr>
-            <a:r>
-              <a:rPr lang="en-US" sz="1200" dirty="0">
-                <a:solidFill>
-                  <a:srgbClr val="334155"/>
-                </a:solidFill>
-                <a:latin typeface="Calibri" pitchFamily="34" charset="0"/>
-                <a:ea typeface="Calibri" pitchFamily="34" charset="-122"/>
-                <a:cs typeface="Calibri" pitchFamily="34" charset="-120"/>
-              </a:rPr>
-              <a:t>Deployment Frequency</a:t>
-            </a:r>
-            <a:endParaRPr lang="en-US" sz="1200" dirty="0"/>
-          </a:p>
-        </p:txBody>
-      </p:sp>
-      <p:sp>
-        <p:nvSpPr>
-          <p:cNvPr id="13" name="Text 11"/>
           <p:cNvSpPr/>
           <p:nvPr/>
         </p:nvSpPr>
@@ -6129,7 +6051,7 @@
       </p:sp>
       <p:sp>
         <p:nvSpPr>
-          <p:cNvPr id="14" name="Shape 12"/>
+          <p:cNvPr id="13" name="Shape 11"/>
           <p:cNvSpPr/>
           <p:nvPr/>
         </p:nvSpPr>
@@ -6163,7 +6085,7 @@
       </p:sp>
       <p:sp>
         <p:nvSpPr>
-          <p:cNvPr id="15" name="Shape 13"/>
+          <p:cNvPr id="14" name="Shape 12"/>
           <p:cNvSpPr/>
           <p:nvPr/>
         </p:nvSpPr>
@@ -6185,13 +6107,52 @@
       </p:sp>
       <p:sp>
         <p:nvSpPr>
+          <p:cNvPr id="15" name="Text 13"/>
+          <p:cNvSpPr/>
+          <p:nvPr/>
+        </p:nvSpPr>
+        <p:spPr>
+          <a:xfrm>
+            <a:off x="3511296" y="2029968"/>
+            <a:ext cx="2350008" cy="640080"/>
+          </a:xfrm>
+          <a:prstGeom prst="rect">
+            <a:avLst/>
+          </a:prstGeom>
+          <a:noFill/>
+          <a:ln/>
+        </p:spPr>
+        <p:txBody>
+          <a:bodyPr wrap="square" lIns="0" tIns="0" rIns="0" bIns="0" rtlCol="0" anchor="ctr"/>
+          <a:lstStyle/>
+          <a:p>
+            <a:pPr indent="0" marL="0">
+              <a:buNone/>
+            </a:pPr>
+            <a:r>
+              <a:rPr lang="en-US" sz="3000" b="1" dirty="0">
+                <a:solidFill>
+                  <a:srgbClr val="0D9488"/>
+                </a:solidFill>
+                <a:latin typeface="Calibri" pitchFamily="34" charset="0"/>
+                <a:ea typeface="Calibri" pitchFamily="34" charset="-122"/>
+                <a:cs typeface="Calibri" pitchFamily="34" charset="-120"/>
+              </a:rPr>
+              <a:t>&lt; 1 jour</a:t>
+            </a:r>
+            <a:endParaRPr lang="en-US" sz="3000" dirty="0"/>
+          </a:p>
+        </p:txBody>
+      </p:sp>
+      <p:sp>
+        <p:nvSpPr>
           <p:cNvPr id="16" name="Text 14"/>
           <p:cNvSpPr/>
           <p:nvPr/>
         </p:nvSpPr>
         <p:spPr>
           <a:xfrm>
-            <a:off x="3511296" y="2029968"/>
+            <a:off x="3511296" y="2724912"/>
             <a:ext cx="2350008" cy="685800"/>
           </a:xfrm>
           <a:prstGeom prst="rect">
@@ -6208,62 +6169,23 @@
               <a:buNone/>
             </a:pPr>
             <a:r>
-              <a:rPr lang="en-US" sz="3000" b="1" dirty="0">
-                <a:solidFill>
-                  <a:srgbClr val="0D9488"/>
-                </a:solidFill>
-                <a:latin typeface="Calibri" pitchFamily="34" charset="0"/>
-                <a:ea typeface="Calibri" pitchFamily="34" charset="-122"/>
-                <a:cs typeface="Calibri" pitchFamily="34" charset="-120"/>
-              </a:rPr>
-              <a:t>&lt; 1 jour</a:t>
-            </a:r>
-            <a:endParaRPr lang="en-US" sz="3000" dirty="0"/>
+              <a:rPr lang="en-US" sz="1200" dirty="0">
+                <a:solidFill>
+                  <a:srgbClr val="334155"/>
+                </a:solidFill>
+                <a:latin typeface="Calibri" pitchFamily="34" charset="0"/>
+                <a:ea typeface="Calibri" pitchFamily="34" charset="-122"/>
+                <a:cs typeface="Calibri" pitchFamily="34" charset="-120"/>
+              </a:rPr>
+              <a:t>Lead Time for Changes</a:t>
+            </a:r>
+            <a:endParaRPr lang="en-US" sz="1200" dirty="0"/>
           </a:p>
         </p:txBody>
       </p:sp>
       <p:sp>
         <p:nvSpPr>
           <p:cNvPr id="17" name="Text 15"/>
-          <p:cNvSpPr/>
-          <p:nvPr/>
-        </p:nvSpPr>
-        <p:spPr>
-          <a:xfrm>
-            <a:off x="3511296" y="2761488"/>
-            <a:ext cx="2350008" cy="685800"/>
-          </a:xfrm>
-          <a:prstGeom prst="rect">
-            <a:avLst/>
-          </a:prstGeom>
-          <a:noFill/>
-          <a:ln/>
-        </p:spPr>
-        <p:txBody>
-          <a:bodyPr wrap="square" lIns="0" tIns="0" rIns="0" bIns="0" rtlCol="0" anchor="ctr"/>
-          <a:lstStyle/>
-          <a:p>
-            <a:pPr indent="0" marL="0">
-              <a:buNone/>
-            </a:pPr>
-            <a:r>
-              <a:rPr lang="en-US" sz="1200" dirty="0">
-                <a:solidFill>
-                  <a:srgbClr val="334155"/>
-                </a:solidFill>
-                <a:latin typeface="Calibri" pitchFamily="34" charset="0"/>
-                <a:ea typeface="Calibri" pitchFamily="34" charset="-122"/>
-                <a:cs typeface="Calibri" pitchFamily="34" charset="-120"/>
-              </a:rPr>
-              <a:t>Lead Time for Changes</a:t>
-            </a:r>
-            <a:endParaRPr lang="en-US" sz="1200" dirty="0"/>
-          </a:p>
-        </p:txBody>
-      </p:sp>
-      <p:sp>
-        <p:nvSpPr>
-          <p:cNvPr id="18" name="Text 16"/>
           <p:cNvSpPr/>
           <p:nvPr/>
         </p:nvSpPr>
@@ -6302,7 +6224,7 @@
       </p:sp>
       <p:sp>
         <p:nvSpPr>
-          <p:cNvPr id="19" name="Shape 17"/>
+          <p:cNvPr id="18" name="Shape 16"/>
           <p:cNvSpPr/>
           <p:nvPr/>
         </p:nvSpPr>
@@ -6336,7 +6258,7 @@
       </p:sp>
       <p:sp>
         <p:nvSpPr>
-          <p:cNvPr id="20" name="Shape 18"/>
+          <p:cNvPr id="19" name="Shape 17"/>
           <p:cNvSpPr/>
           <p:nvPr/>
         </p:nvSpPr>
@@ -6358,13 +6280,52 @@
       </p:sp>
       <p:sp>
         <p:nvSpPr>
+          <p:cNvPr id="20" name="Text 18"/>
+          <p:cNvSpPr/>
+          <p:nvPr/>
+        </p:nvSpPr>
+        <p:spPr>
+          <a:xfrm>
+            <a:off x="6336792" y="2029968"/>
+            <a:ext cx="2350008" cy="640080"/>
+          </a:xfrm>
+          <a:prstGeom prst="rect">
+            <a:avLst/>
+          </a:prstGeom>
+          <a:noFill/>
+          <a:ln/>
+        </p:spPr>
+        <p:txBody>
+          <a:bodyPr wrap="square" lIns="0" tIns="0" rIns="0" bIns="0" rtlCol="0" anchor="ctr"/>
+          <a:lstStyle/>
+          <a:p>
+            <a:pPr indent="0" marL="0">
+              <a:buNone/>
+            </a:pPr>
+            <a:r>
+              <a:rPr lang="en-US" sz="3000" b="1" dirty="0">
+                <a:solidFill>
+                  <a:srgbClr val="15803D"/>
+                </a:solidFill>
+                <a:latin typeface="Calibri" pitchFamily="34" charset="0"/>
+                <a:ea typeface="Calibri" pitchFamily="34" charset="-122"/>
+                <a:cs typeface="Calibri" pitchFamily="34" charset="-120"/>
+              </a:rPr>
+              <a:t>0–15 %</a:t>
+            </a:r>
+            <a:endParaRPr lang="en-US" sz="3000" dirty="0"/>
+          </a:p>
+        </p:txBody>
+      </p:sp>
+      <p:sp>
+        <p:nvSpPr>
           <p:cNvPr id="21" name="Text 19"/>
           <p:cNvSpPr/>
           <p:nvPr/>
         </p:nvSpPr>
         <p:spPr>
           <a:xfrm>
-            <a:off x="6336792" y="2029968"/>
+            <a:off x="6336792" y="2724912"/>
             <a:ext cx="2350008" cy="685800"/>
           </a:xfrm>
           <a:prstGeom prst="rect">
@@ -6381,62 +6342,23 @@
               <a:buNone/>
             </a:pPr>
             <a:r>
-              <a:rPr lang="en-US" sz="3000" b="1" dirty="0">
-                <a:solidFill>
-                  <a:srgbClr val="15803D"/>
-                </a:solidFill>
-                <a:latin typeface="Calibri" pitchFamily="34" charset="0"/>
-                <a:ea typeface="Calibri" pitchFamily="34" charset="-122"/>
-                <a:cs typeface="Calibri" pitchFamily="34" charset="-120"/>
-              </a:rPr>
-              <a:t>0–15 %</a:t>
-            </a:r>
-            <a:endParaRPr lang="en-US" sz="3000" dirty="0"/>
+              <a:rPr lang="en-US" sz="1200" dirty="0">
+                <a:solidFill>
+                  <a:srgbClr val="334155"/>
+                </a:solidFill>
+                <a:latin typeface="Calibri" pitchFamily="34" charset="0"/>
+                <a:ea typeface="Calibri" pitchFamily="34" charset="-122"/>
+                <a:cs typeface="Calibri" pitchFamily="34" charset="-120"/>
+              </a:rPr>
+              <a:t>Change Failure Rate</a:t>
+            </a:r>
+            <a:endParaRPr lang="en-US" sz="1200" dirty="0"/>
           </a:p>
         </p:txBody>
       </p:sp>
       <p:sp>
         <p:nvSpPr>
           <p:cNvPr id="22" name="Text 20"/>
-          <p:cNvSpPr/>
-          <p:nvPr/>
-        </p:nvSpPr>
-        <p:spPr>
-          <a:xfrm>
-            <a:off x="6336792" y="2761488"/>
-            <a:ext cx="2350008" cy="685800"/>
-          </a:xfrm>
-          <a:prstGeom prst="rect">
-            <a:avLst/>
-          </a:prstGeom>
-          <a:noFill/>
-          <a:ln/>
-        </p:spPr>
-        <p:txBody>
-          <a:bodyPr wrap="square" lIns="0" tIns="0" rIns="0" bIns="0" rtlCol="0" anchor="ctr"/>
-          <a:lstStyle/>
-          <a:p>
-            <a:pPr indent="0" marL="0">
-              <a:buNone/>
-            </a:pPr>
-            <a:r>
-              <a:rPr lang="en-US" sz="1200" dirty="0">
-                <a:solidFill>
-                  <a:srgbClr val="334155"/>
-                </a:solidFill>
-                <a:latin typeface="Calibri" pitchFamily="34" charset="0"/>
-                <a:ea typeface="Calibri" pitchFamily="34" charset="-122"/>
-                <a:cs typeface="Calibri" pitchFamily="34" charset="-120"/>
-              </a:rPr>
-              <a:t>Change Failure Rate</a:t>
-            </a:r>
-            <a:endParaRPr lang="en-US" sz="1200" dirty="0"/>
-          </a:p>
-        </p:txBody>
-      </p:sp>
-      <p:sp>
-        <p:nvSpPr>
-          <p:cNvPr id="23" name="Text 21"/>
           <p:cNvSpPr/>
           <p:nvPr/>
         </p:nvSpPr>
@@ -6475,7 +6397,7 @@
       </p:sp>
       <p:sp>
         <p:nvSpPr>
-          <p:cNvPr id="24" name="Shape 22"/>
+          <p:cNvPr id="23" name="Shape 21"/>
           <p:cNvSpPr/>
           <p:nvPr/>
         </p:nvSpPr>
@@ -6509,7 +6431,7 @@
       </p:sp>
       <p:sp>
         <p:nvSpPr>
-          <p:cNvPr id="25" name="Shape 23"/>
+          <p:cNvPr id="24" name="Shape 22"/>
           <p:cNvSpPr/>
           <p:nvPr/>
         </p:nvSpPr>
@@ -6531,13 +6453,52 @@
       </p:sp>
       <p:sp>
         <p:nvSpPr>
+          <p:cNvPr id="25" name="Text 23"/>
+          <p:cNvSpPr/>
+          <p:nvPr/>
+        </p:nvSpPr>
+        <p:spPr>
+          <a:xfrm>
+            <a:off x="9162288" y="2029968"/>
+            <a:ext cx="2350008" cy="640080"/>
+          </a:xfrm>
+          <a:prstGeom prst="rect">
+            <a:avLst/>
+          </a:prstGeom>
+          <a:noFill/>
+          <a:ln/>
+        </p:spPr>
+        <p:txBody>
+          <a:bodyPr wrap="square" lIns="0" tIns="0" rIns="0" bIns="0" rtlCol="0" anchor="ctr"/>
+          <a:lstStyle/>
+          <a:p>
+            <a:pPr indent="0" marL="0">
+              <a:buNone/>
+            </a:pPr>
+            <a:r>
+              <a:rPr lang="en-US" sz="3000" b="1" dirty="0">
+                <a:solidFill>
+                  <a:srgbClr val="6D28D9"/>
+                </a:solidFill>
+                <a:latin typeface="Calibri" pitchFamily="34" charset="0"/>
+                <a:ea typeface="Calibri" pitchFamily="34" charset="-122"/>
+                <a:cs typeface="Calibri" pitchFamily="34" charset="-120"/>
+              </a:rPr>
+              <a:t>&lt; 1 h</a:t>
+            </a:r>
+            <a:endParaRPr lang="en-US" sz="3000" dirty="0"/>
+          </a:p>
+        </p:txBody>
+      </p:sp>
+      <p:sp>
+        <p:nvSpPr>
           <p:cNvPr id="26" name="Text 24"/>
           <p:cNvSpPr/>
           <p:nvPr/>
         </p:nvSpPr>
         <p:spPr>
           <a:xfrm>
-            <a:off x="9162288" y="2029968"/>
+            <a:off x="9162288" y="2724912"/>
             <a:ext cx="2350008" cy="685800"/>
           </a:xfrm>
           <a:prstGeom prst="rect">
@@ -6554,62 +6515,23 @@
               <a:buNone/>
             </a:pPr>
             <a:r>
-              <a:rPr lang="en-US" sz="3000" b="1" dirty="0">
-                <a:solidFill>
-                  <a:srgbClr val="6D28D9"/>
-                </a:solidFill>
-                <a:latin typeface="Calibri" pitchFamily="34" charset="0"/>
-                <a:ea typeface="Calibri" pitchFamily="34" charset="-122"/>
-                <a:cs typeface="Calibri" pitchFamily="34" charset="-120"/>
-              </a:rPr>
-              <a:t>&lt; 1 h</a:t>
-            </a:r>
-            <a:endParaRPr lang="en-US" sz="3000" dirty="0"/>
+              <a:rPr lang="en-US" sz="1200" dirty="0">
+                <a:solidFill>
+                  <a:srgbClr val="334155"/>
+                </a:solidFill>
+                <a:latin typeface="Calibri" pitchFamily="34" charset="0"/>
+                <a:ea typeface="Calibri" pitchFamily="34" charset="-122"/>
+                <a:cs typeface="Calibri" pitchFamily="34" charset="-120"/>
+              </a:rPr>
+              <a:t>MTTR — temps de récupération</a:t>
+            </a:r>
+            <a:endParaRPr lang="en-US" sz="1200" dirty="0"/>
           </a:p>
         </p:txBody>
       </p:sp>
       <p:sp>
         <p:nvSpPr>
           <p:cNvPr id="27" name="Text 25"/>
-          <p:cNvSpPr/>
-          <p:nvPr/>
-        </p:nvSpPr>
-        <p:spPr>
-          <a:xfrm>
-            <a:off x="9162288" y="2761488"/>
-            <a:ext cx="2350008" cy="685800"/>
-          </a:xfrm>
-          <a:prstGeom prst="rect">
-            <a:avLst/>
-          </a:prstGeom>
-          <a:noFill/>
-          <a:ln/>
-        </p:spPr>
-        <p:txBody>
-          <a:bodyPr wrap="square" lIns="0" tIns="0" rIns="0" bIns="0" rtlCol="0" anchor="ctr"/>
-          <a:lstStyle/>
-          <a:p>
-            <a:pPr indent="0" marL="0">
-              <a:buNone/>
-            </a:pPr>
-            <a:r>
-              <a:rPr lang="en-US" sz="1200" dirty="0">
-                <a:solidFill>
-                  <a:srgbClr val="334155"/>
-                </a:solidFill>
-                <a:latin typeface="Calibri" pitchFamily="34" charset="0"/>
-                <a:ea typeface="Calibri" pitchFamily="34" charset="-122"/>
-                <a:cs typeface="Calibri" pitchFamily="34" charset="-120"/>
-              </a:rPr>
-              <a:t>MTTR — temps de récupération</a:t>
-            </a:r>
-            <a:endParaRPr lang="en-US" sz="1200" dirty="0"/>
-          </a:p>
-        </p:txBody>
-      </p:sp>
-      <p:sp>
-        <p:nvSpPr>
-          <p:cNvPr id="28" name="Text 26"/>
           <p:cNvSpPr/>
           <p:nvPr/>
         </p:nvSpPr>
@@ -6648,7 +6570,7 @@
       </p:sp>
       <p:sp>
         <p:nvSpPr>
-          <p:cNvPr id="29" name="Shape 27"/>
+          <p:cNvPr id="28" name="Shape 26"/>
           <p:cNvSpPr/>
           <p:nvPr/>
         </p:nvSpPr>
@@ -6682,7 +6604,7 @@
       </p:sp>
       <p:sp>
         <p:nvSpPr>
-          <p:cNvPr id="30" name="Text 28"/>
+          <p:cNvPr id="29" name="Text 27"/>
           <p:cNvSpPr/>
           <p:nvPr/>
         </p:nvSpPr>
@@ -6721,7 +6643,7 @@
       </p:sp>
       <p:sp>
         <p:nvSpPr>
-          <p:cNvPr id="31" name="Text 29"/>
+          <p:cNvPr id="30" name="Text 28"/>
           <p:cNvSpPr/>
           <p:nvPr/>
         </p:nvSpPr>
@@ -6760,7 +6682,7 @@
       </p:sp>
       <p:sp>
         <p:nvSpPr>
-          <p:cNvPr id="32" name="Text 30"/>
+          <p:cNvPr id="31" name="Text 29"/>
           <p:cNvSpPr/>
           <p:nvPr/>
         </p:nvSpPr>
@@ -12931,7 +12853,7 @@
         <p:spPr>
           <a:xfrm>
             <a:off x="685800" y="5001768"/>
-            <a:ext cx="5120640" cy="685800"/>
+            <a:ext cx="5120640" cy="640080"/>
           </a:xfrm>
           <a:prstGeom prst="rect">
             <a:avLst/>
@@ -12969,8 +12891,8 @@
         </p:nvSpPr>
         <p:spPr>
           <a:xfrm>
-            <a:off x="685800" y="5733288"/>
-            <a:ext cx="5120640" cy="685800"/>
+            <a:off x="685800" y="5696712"/>
+            <a:ext cx="5120640" cy="411480"/>
           </a:xfrm>
           <a:prstGeom prst="rect">
             <a:avLst/>
@@ -13065,7 +12987,7 @@
         <p:spPr>
           <a:xfrm>
             <a:off x="6400800" y="5001768"/>
-            <a:ext cx="5120640" cy="685800"/>
+            <a:ext cx="5120640" cy="640080"/>
           </a:xfrm>
           <a:prstGeom prst="rect">
             <a:avLst/>
@@ -13103,8 +13025,8 @@
         </p:nvSpPr>
         <p:spPr>
           <a:xfrm>
-            <a:off x="6400800" y="5733288"/>
-            <a:ext cx="5120640" cy="685800"/>
+            <a:off x="6400800" y="5696712"/>
+            <a:ext cx="5120640" cy="411480"/>
           </a:xfrm>
           <a:prstGeom prst="rect">
             <a:avLst/>
@@ -13142,7 +13064,7 @@
         </p:nvSpPr>
         <p:spPr>
           <a:xfrm>
-            <a:off x="502920" y="6199632"/>
+            <a:off x="502920" y="6263640"/>
             <a:ext cx="10972800" cy="274320"/>
           </a:xfrm>
           <a:prstGeom prst="rect">

</xml_diff>